<commit_message>
Pitch deck: add "You save, every year" row (₹3.48L / ₹11.88L / ₹23.4L)
Yearly = verified monthly savings x 12, as the table's green closing row; fine
print adds first-year figures net of one-time setup for full honesty.

Co-Authored-By: Claude Opus 4.8 <noreply@anthropic.com>
</commit_message>
<xml_diff>
--- a/Admissions-AI-Pitch.pptx
+++ b/Admissions-AI-Pitch.pptx
@@ -3858,7 +3858,7 @@
           </p:nvPr>
         </p:nvGraphicFramePr>
         <p:xfrm>
-          <a:off x="640080" y="1508760"/>
+          <a:off x="640080" y="1463040"/>
           <a:ext cx="10908792" cy="914400"/>
         </p:xfrm>
         <a:graphic>
@@ -3871,7 +3871,7 @@
                 <a:gridCol w="2377440"/>
                 <a:gridCol w="2377440"/>
               </a:tblGrid>
-              <a:tr h="475488">
+              <a:tr h="438912">
                 <a:tc>
                   <a:txBody>
                     <a:bodyPr/>
@@ -4134,7 +4134,7 @@
                   </a:tcPr>
                 </a:tc>
               </a:tr>
-              <a:tr h="475488">
+              <a:tr h="438912">
                 <a:tc>
                   <a:txBody>
                     <a:bodyPr/>
@@ -4408,7 +4408,7 @@
                   </a:tcPr>
                 </a:tc>
               </a:tr>
-              <a:tr h="475488">
+              <a:tr h="438912">
                 <a:tc>
                   <a:txBody>
                     <a:bodyPr/>
@@ -4682,7 +4682,7 @@
                   </a:tcPr>
                 </a:tc>
               </a:tr>
-              <a:tr h="475488">
+              <a:tr h="438912">
                 <a:tc>
                   <a:txBody>
                     <a:bodyPr/>
@@ -4956,7 +4956,7 @@
                   </a:tcPr>
                 </a:tc>
               </a:tr>
-              <a:tr h="475488">
+              <a:tr h="438912">
                 <a:tc>
                   <a:txBody>
                     <a:bodyPr/>
@@ -5230,7 +5230,7 @@
                   </a:tcPr>
                 </a:tc>
               </a:tr>
-              <a:tr h="475488">
+              <a:tr h="438912">
                 <a:tc>
                   <a:txBody>
                     <a:bodyPr/>
@@ -5504,7 +5504,7 @@
                   </a:tcPr>
                 </a:tc>
               </a:tr>
-              <a:tr h="475488">
+              <a:tr h="438912">
                 <a:tc>
                   <a:txBody>
                     <a:bodyPr/>
@@ -5778,6 +5778,280 @@
                   </a:tcPr>
                 </a:tc>
               </a:tr>
+              <a:tr h="438912">
+                <a:tc>
+                  <a:txBody>
+                    <a:bodyPr/>
+                    <a:lstStyle/>
+                    <a:p>
+                      <a:pPr indent="0" marL="0">
+                        <a:buNone/>
+                      </a:pPr>
+                      <a:r>
+                        <a:rPr lang="en-US" sz="1250" b="1" dirty="0">
+                          <a:solidFill>
+                            <a:srgbClr val="2A211C"/>
+                          </a:solidFill>
+                          <a:latin typeface="Calibri" pitchFamily="34" charset="0"/>
+                          <a:ea typeface="Calibri" pitchFamily="34" charset="-122"/>
+                          <a:cs typeface="Calibri" pitchFamily="34" charset="-120"/>
+                        </a:rPr>
+                        <a:t>You save, every year</a:t>
+                      </a:r>
+                      <a:endParaRPr lang="en-US" sz="1250" dirty="0">
+                        <a:latin typeface="Calibri" charset="0"/>
+                        <a:ea typeface="Calibri" charset="0"/>
+                        <a:cs typeface="Calibri" charset="0"/>
+                      </a:endParaRPr>
+                    </a:p>
+                  </a:txBody>
+                  <a:tcPr marL="64008" marR="64008" marT="64008" marB="64008" anchor="ctr">
+                    <a:lnL w="6350" cap="flat" cmpd="sng" algn="ctr">
+                      <a:solidFill>
+                        <a:srgbClr val="D9CCBB"/>
+                      </a:solidFill>
+                      <a:prstDash val="solid"/>
+                      <a:round/>
+                      <a:headEnd type="none" w="med" len="med"/>
+                      <a:tailEnd type="none" w="med" len="med"/>
+                    </a:lnL>
+                    <a:lnR w="6350" cap="flat" cmpd="sng" algn="ctr">
+                      <a:solidFill>
+                        <a:srgbClr val="D9CCBB"/>
+                      </a:solidFill>
+                      <a:prstDash val="solid"/>
+                      <a:round/>
+                      <a:headEnd type="none" w="med" len="med"/>
+                      <a:tailEnd type="none" w="med" len="med"/>
+                    </a:lnR>
+                    <a:lnT w="6350" cap="flat" cmpd="sng" algn="ctr">
+                      <a:solidFill>
+                        <a:srgbClr val="D9CCBB"/>
+                      </a:solidFill>
+                      <a:prstDash val="solid"/>
+                      <a:round/>
+                      <a:headEnd type="none" w="med" len="med"/>
+                      <a:tailEnd type="none" w="med" len="med"/>
+                    </a:lnT>
+                    <a:lnB w="6350" cap="flat" cmpd="sng" algn="ctr">
+                      <a:solidFill>
+                        <a:srgbClr val="D9CCBB"/>
+                      </a:solidFill>
+                      <a:prstDash val="solid"/>
+                      <a:round/>
+                      <a:headEnd type="none" w="med" len="med"/>
+                      <a:tailEnd type="none" w="med" len="med"/>
+                    </a:lnB>
+                    <a:solidFill>
+                      <a:srgbClr val="E9F2EA"/>
+                    </a:solidFill>
+                  </a:tcPr>
+                </a:tc>
+                <a:tc>
+                  <a:txBody>
+                    <a:bodyPr/>
+                    <a:lstStyle/>
+                    <a:p>
+                      <a:pPr algn="ctr" indent="0" marL="0">
+                        <a:buNone/>
+                      </a:pPr>
+                      <a:r>
+                        <a:rPr lang="en-US" sz="1400" b="1" dirty="0">
+                          <a:solidFill>
+                            <a:srgbClr val="2E7D4F"/>
+                          </a:solidFill>
+                          <a:latin typeface="Calibri" pitchFamily="34" charset="0"/>
+                          <a:ea typeface="Calibri" pitchFamily="34" charset="-122"/>
+                          <a:cs typeface="Calibri" pitchFamily="34" charset="-120"/>
+                        </a:rPr>
+                        <a:t>≈ ₹3,48,000</a:t>
+                      </a:r>
+                      <a:endParaRPr lang="en-US" sz="1400" dirty="0">
+                        <a:latin typeface="Calibri" charset="0"/>
+                        <a:ea typeface="Calibri" charset="0"/>
+                        <a:cs typeface="Calibri" charset="0"/>
+                      </a:endParaRPr>
+                    </a:p>
+                  </a:txBody>
+                  <a:tcPr marL="64008" marR="64008" marT="64008" marB="64008" anchor="ctr">
+                    <a:lnL w="6350" cap="flat" cmpd="sng" algn="ctr">
+                      <a:solidFill>
+                        <a:srgbClr val="D9CCBB"/>
+                      </a:solidFill>
+                      <a:prstDash val="solid"/>
+                      <a:round/>
+                      <a:headEnd type="none" w="med" len="med"/>
+                      <a:tailEnd type="none" w="med" len="med"/>
+                    </a:lnL>
+                    <a:lnR w="6350" cap="flat" cmpd="sng" algn="ctr">
+                      <a:solidFill>
+                        <a:srgbClr val="D9CCBB"/>
+                      </a:solidFill>
+                      <a:prstDash val="solid"/>
+                      <a:round/>
+                      <a:headEnd type="none" w="med" len="med"/>
+                      <a:tailEnd type="none" w="med" len="med"/>
+                    </a:lnR>
+                    <a:lnT w="6350" cap="flat" cmpd="sng" algn="ctr">
+                      <a:solidFill>
+                        <a:srgbClr val="D9CCBB"/>
+                      </a:solidFill>
+                      <a:prstDash val="solid"/>
+                      <a:round/>
+                      <a:headEnd type="none" w="med" len="med"/>
+                      <a:tailEnd type="none" w="med" len="med"/>
+                    </a:lnT>
+                    <a:lnB w="6350" cap="flat" cmpd="sng" algn="ctr">
+                      <a:solidFill>
+                        <a:srgbClr val="D9CCBB"/>
+                      </a:solidFill>
+                      <a:prstDash val="solid"/>
+                      <a:round/>
+                      <a:headEnd type="none" w="med" len="med"/>
+                      <a:tailEnd type="none" w="med" len="med"/>
+                    </a:lnB>
+                    <a:solidFill>
+                      <a:srgbClr val="E9F2EA"/>
+                    </a:solidFill>
+                  </a:tcPr>
+                </a:tc>
+                <a:tc>
+                  <a:txBody>
+                    <a:bodyPr/>
+                    <a:lstStyle/>
+                    <a:p>
+                      <a:pPr algn="ctr" indent="0" marL="0">
+                        <a:buNone/>
+                      </a:pPr>
+                      <a:r>
+                        <a:rPr lang="en-US" sz="1400" b="1" dirty="0">
+                          <a:solidFill>
+                            <a:srgbClr val="2E7D4F"/>
+                          </a:solidFill>
+                          <a:latin typeface="Calibri" pitchFamily="34" charset="0"/>
+                          <a:ea typeface="Calibri" pitchFamily="34" charset="-122"/>
+                          <a:cs typeface="Calibri" pitchFamily="34" charset="-120"/>
+                        </a:rPr>
+                        <a:t>≈ ₹11,88,000</a:t>
+                      </a:r>
+                      <a:endParaRPr lang="en-US" sz="1400" dirty="0">
+                        <a:latin typeface="Calibri" charset="0"/>
+                        <a:ea typeface="Calibri" charset="0"/>
+                        <a:cs typeface="Calibri" charset="0"/>
+                      </a:endParaRPr>
+                    </a:p>
+                  </a:txBody>
+                  <a:tcPr marL="64008" marR="64008" marT="64008" marB="64008" anchor="ctr">
+                    <a:lnL w="6350" cap="flat" cmpd="sng" algn="ctr">
+                      <a:solidFill>
+                        <a:srgbClr val="D9CCBB"/>
+                      </a:solidFill>
+                      <a:prstDash val="solid"/>
+                      <a:round/>
+                      <a:headEnd type="none" w="med" len="med"/>
+                      <a:tailEnd type="none" w="med" len="med"/>
+                    </a:lnL>
+                    <a:lnR w="6350" cap="flat" cmpd="sng" algn="ctr">
+                      <a:solidFill>
+                        <a:srgbClr val="D9CCBB"/>
+                      </a:solidFill>
+                      <a:prstDash val="solid"/>
+                      <a:round/>
+                      <a:headEnd type="none" w="med" len="med"/>
+                      <a:tailEnd type="none" w="med" len="med"/>
+                    </a:lnR>
+                    <a:lnT w="6350" cap="flat" cmpd="sng" algn="ctr">
+                      <a:solidFill>
+                        <a:srgbClr val="D9CCBB"/>
+                      </a:solidFill>
+                      <a:prstDash val="solid"/>
+                      <a:round/>
+                      <a:headEnd type="none" w="med" len="med"/>
+                      <a:tailEnd type="none" w="med" len="med"/>
+                    </a:lnT>
+                    <a:lnB w="6350" cap="flat" cmpd="sng" algn="ctr">
+                      <a:solidFill>
+                        <a:srgbClr val="D9CCBB"/>
+                      </a:solidFill>
+                      <a:prstDash val="solid"/>
+                      <a:round/>
+                      <a:headEnd type="none" w="med" len="med"/>
+                      <a:tailEnd type="none" w="med" len="med"/>
+                    </a:lnB>
+                    <a:solidFill>
+                      <a:srgbClr val="E9F2EA"/>
+                    </a:solidFill>
+                  </a:tcPr>
+                </a:tc>
+                <a:tc>
+                  <a:txBody>
+                    <a:bodyPr/>
+                    <a:lstStyle/>
+                    <a:p>
+                      <a:pPr algn="ctr" indent="0" marL="0">
+                        <a:buNone/>
+                      </a:pPr>
+                      <a:r>
+                        <a:rPr lang="en-US" sz="1400" b="1" dirty="0">
+                          <a:solidFill>
+                            <a:srgbClr val="2E7D4F"/>
+                          </a:solidFill>
+                          <a:latin typeface="Calibri" pitchFamily="34" charset="0"/>
+                          <a:ea typeface="Calibri" pitchFamily="34" charset="-122"/>
+                          <a:cs typeface="Calibri" pitchFamily="34" charset="-120"/>
+                        </a:rPr>
+                        <a:t>≈ ₹23,40,000</a:t>
+                      </a:r>
+                      <a:endParaRPr lang="en-US" sz="1400" dirty="0">
+                        <a:latin typeface="Calibri" charset="0"/>
+                        <a:ea typeface="Calibri" charset="0"/>
+                        <a:cs typeface="Calibri" charset="0"/>
+                      </a:endParaRPr>
+                    </a:p>
+                  </a:txBody>
+                  <a:tcPr marL="64008" marR="64008" marT="64008" marB="64008" anchor="ctr">
+                    <a:lnL w="6350" cap="flat" cmpd="sng" algn="ctr">
+                      <a:solidFill>
+                        <a:srgbClr val="D9CCBB"/>
+                      </a:solidFill>
+                      <a:prstDash val="solid"/>
+                      <a:round/>
+                      <a:headEnd type="none" w="med" len="med"/>
+                      <a:tailEnd type="none" w="med" len="med"/>
+                    </a:lnL>
+                    <a:lnR w="6350" cap="flat" cmpd="sng" algn="ctr">
+                      <a:solidFill>
+                        <a:srgbClr val="D9CCBB"/>
+                      </a:solidFill>
+                      <a:prstDash val="solid"/>
+                      <a:round/>
+                      <a:headEnd type="none" w="med" len="med"/>
+                      <a:tailEnd type="none" w="med" len="med"/>
+                    </a:lnR>
+                    <a:lnT w="6350" cap="flat" cmpd="sng" algn="ctr">
+                      <a:solidFill>
+                        <a:srgbClr val="D9CCBB"/>
+                      </a:solidFill>
+                      <a:prstDash val="solid"/>
+                      <a:round/>
+                      <a:headEnd type="none" w="med" len="med"/>
+                      <a:tailEnd type="none" w="med" len="med"/>
+                    </a:lnT>
+                    <a:lnB w="6350" cap="flat" cmpd="sng" algn="ctr">
+                      <a:solidFill>
+                        <a:srgbClr val="D9CCBB"/>
+                      </a:solidFill>
+                      <a:prstDash val="solid"/>
+                      <a:round/>
+                      <a:headEnd type="none" w="med" len="med"/>
+                      <a:tailEnd type="none" w="med" len="med"/>
+                    </a:lnB>
+                    <a:solidFill>
+                      <a:srgbClr val="E9F2EA"/>
+                    </a:solidFill>
+                  </a:tcPr>
+                </a:tc>
+              </a:tr>
             </a:tbl>
           </a:graphicData>
         </a:graphic>
@@ -5790,7 +6064,7 @@
         </p:nvSpPr>
         <p:spPr>
           <a:xfrm>
-            <a:off x="640080" y="5257800"/>
+            <a:off x="640080" y="5440680"/>
             <a:ext cx="10881360" cy="502920"/>
           </a:xfrm>
           <a:prstGeom prst="rect">
@@ -5829,8 +6103,8 @@
         </p:nvSpPr>
         <p:spPr>
           <a:xfrm>
-            <a:off x="640080" y="5897880"/>
-            <a:ext cx="10881360" cy="502920"/>
+            <a:off x="640080" y="6035040"/>
+            <a:ext cx="10881360" cy="548640"/>
           </a:xfrm>
           <a:prstGeom prst="rect">
             <a:avLst/>
@@ -5854,7 +6128,7 @@
                 <a:ea typeface="Calibri" pitchFamily="34" charset="-122"/>
                 <a:cs typeface="Calibri" pitchFamily="34" charset="-120"/>
               </a:rPr>
-              <a:t>Vendor accounts in your name, bills visible to you, +GST as applicable. Monthly totals assume modelled call volumes; your real bill follows your real minutes.</a:t>
+              <a:t>Vendor accounts in your name, bills visible to you, +GST as applicable. Monthly totals assume modelled call volumes; your real bill follows your real minutes. First-year saving net of one-time setup: ≈ ₹2,98,000 · ₹10,88,000 · ₹21,90,000.</a:t>
             </a:r>
             <a:endParaRPr lang="en-US" sz="1050" dirty="0"/>
           </a:p>

</xml_diff>

<commit_message>
Generic deck: raise management fee to 25k/75k/1.25L (setup unchanged), cascade all figures
Matches the revised fee tier; setup stays 50k/1L/1.5L (the affordable "any college"
version). Recomputed total outflow, monthly & yearly savings, first-year-net-of-setup,
slide-12 full-year fee (3.5-16.5L) and break-even admissions (2-8). Replaced the now-
false "keep 3-4 per 1" hook with the honest salary-plus-admissions line; also fixed a
latent slide-12 bug where the full-year fee had excluded setup.

Co-Authored-By: Claude Opus 4.8 <noreply@anthropic.com>
</commit_message>
<xml_diff>
--- a/Admissions-AI-Pitch.pptx
+++ b/Admissions-AI-Pitch.pptx
@@ -778,7 +778,7 @@
           <a:p>
             <a:r>
               <a:rPr lang="en-US" dirty="0"/>
-              <a:t>The 10x slide. Deliver slowly: "She does not need to be perfect. She needs to save one or two admissions a year that a missed call would have lost. Everything past that is profit — and we have not even counted the salaries yet."</a:t>
+              <a:t>The 10x slide. Deliver slowly: "She does not need to be perfect. She needs to save a few admissions a year that a missed call would have lost. Everything past that is profit — and we have not even counted the salaries yet."</a:t>
             </a:r>
             <a:endParaRPr lang="en-US" dirty="0"/>
           </a:p>
@@ -4768,7 +4768,7 @@
                           <a:ea typeface="Calibri" pitchFamily="34" charset="-122"/>
                           <a:cs typeface="Calibri" pitchFamily="34" charset="-120"/>
                         </a:rPr>
-                        <a:t>₹10,000</a:t>
+                        <a:t>₹25,000</a:t>
                       </a:r>
                       <a:endParaRPr lang="en-US" sz="1250" dirty="0">
                         <a:latin typeface="Calibri" charset="0"/>
@@ -4836,7 +4836,7 @@
                           <a:ea typeface="Calibri" pitchFamily="34" charset="-122"/>
                           <a:cs typeface="Calibri" pitchFamily="34" charset="-120"/>
                         </a:rPr>
-                        <a:t>₹25,000</a:t>
+                        <a:t>₹75,000</a:t>
                       </a:r>
                       <a:endParaRPr lang="en-US" sz="1250" dirty="0">
                         <a:latin typeface="Calibri" charset="0"/>
@@ -4904,7 +4904,7 @@
                           <a:ea typeface="Calibri" pitchFamily="34" charset="-122"/>
                           <a:cs typeface="Calibri" pitchFamily="34" charset="-120"/>
                         </a:rPr>
-                        <a:t>₹50,000</a:t>
+                        <a:t>₹1,25,000</a:t>
                       </a:r>
                       <a:endParaRPr lang="en-US" sz="1250" dirty="0">
                         <a:latin typeface="Calibri" charset="0"/>
@@ -5042,7 +5042,7 @@
                           <a:ea typeface="Calibri" pitchFamily="34" charset="-122"/>
                           <a:cs typeface="Calibri" pitchFamily="34" charset="-120"/>
                         </a:rPr>
-                        <a:t>≈ ₹46,000</a:t>
+                        <a:t>≈ ₹61,000</a:t>
                       </a:r>
                       <a:endParaRPr lang="en-US" sz="1250" dirty="0">
                         <a:latin typeface="Calibri" charset="0"/>
@@ -5110,7 +5110,7 @@
                           <a:ea typeface="Calibri" pitchFamily="34" charset="-122"/>
                           <a:cs typeface="Calibri" pitchFamily="34" charset="-120"/>
                         </a:rPr>
-                        <a:t>≈ ₹1,26,000</a:t>
+                        <a:t>≈ ₹1,76,000</a:t>
                       </a:r>
                       <a:endParaRPr lang="en-US" sz="1250" dirty="0">
                         <a:latin typeface="Calibri" charset="0"/>
@@ -5178,7 +5178,7 @@
                           <a:ea typeface="Calibri" pitchFamily="34" charset="-122"/>
                           <a:cs typeface="Calibri" pitchFamily="34" charset="-120"/>
                         </a:rPr>
-                        <a:t>≈ ₹2,55,000</a:t>
+                        <a:t>≈ ₹3,30,000</a:t>
                       </a:r>
                       <a:endParaRPr lang="en-US" sz="1250" dirty="0">
                         <a:latin typeface="Calibri" charset="0"/>
@@ -5590,7 +5590,7 @@
                           <a:ea typeface="Calibri" pitchFamily="34" charset="-122"/>
                           <a:cs typeface="Calibri" pitchFamily="34" charset="-120"/>
                         </a:rPr>
-                        <a:t>≈ ₹29,000 (39%)</a:t>
+                        <a:t>≈ ₹14,000 (19%)</a:t>
                       </a:r>
                       <a:endParaRPr lang="en-US" sz="1250" dirty="0">
                         <a:latin typeface="Calibri" charset="0"/>
@@ -5658,7 +5658,7 @@
                           <a:ea typeface="Calibri" pitchFamily="34" charset="-122"/>
                           <a:cs typeface="Calibri" pitchFamily="34" charset="-120"/>
                         </a:rPr>
-                        <a:t>≈ ₹99,000 (44%)</a:t>
+                        <a:t>≈ ₹49,000 (22%)</a:t>
                       </a:r>
                       <a:endParaRPr lang="en-US" sz="1250" dirty="0">
                         <a:latin typeface="Calibri" charset="0"/>
@@ -5726,7 +5726,7 @@
                           <a:ea typeface="Calibri" pitchFamily="34" charset="-122"/>
                           <a:cs typeface="Calibri" pitchFamily="34" charset="-120"/>
                         </a:rPr>
-                        <a:t>≈ ₹1,95,000 (43%)</a:t>
+                        <a:t>≈ ₹1,20,000 (27%)</a:t>
                       </a:r>
                       <a:endParaRPr lang="en-US" sz="1250" dirty="0">
                         <a:latin typeface="Calibri" charset="0"/>
@@ -5864,7 +5864,7 @@
                           <a:ea typeface="Calibri" pitchFamily="34" charset="-122"/>
                           <a:cs typeface="Calibri" pitchFamily="34" charset="-120"/>
                         </a:rPr>
-                        <a:t>≈ ₹3,48,000</a:t>
+                        <a:t>≈ ₹1,68,000</a:t>
                       </a:r>
                       <a:endParaRPr lang="en-US" sz="1400" dirty="0">
                         <a:latin typeface="Calibri" charset="0"/>
@@ -5932,7 +5932,7 @@
                           <a:ea typeface="Calibri" pitchFamily="34" charset="-122"/>
                           <a:cs typeface="Calibri" pitchFamily="34" charset="-120"/>
                         </a:rPr>
-                        <a:t>≈ ₹11,88,000</a:t>
+                        <a:t>≈ ₹5,88,000</a:t>
                       </a:r>
                       <a:endParaRPr lang="en-US" sz="1400" dirty="0">
                         <a:latin typeface="Calibri" charset="0"/>
@@ -6000,7 +6000,7 @@
                           <a:ea typeface="Calibri" pitchFamily="34" charset="-122"/>
                           <a:cs typeface="Calibri" pitchFamily="34" charset="-120"/>
                         </a:rPr>
-                        <a:t>≈ ₹23,40,000</a:t>
+                        <a:t>≈ ₹14,40,000</a:t>
                       </a:r>
                       <a:endParaRPr lang="en-US" sz="1400" dirty="0">
                         <a:latin typeface="Calibri" charset="0"/>
@@ -6081,7 +6081,7 @@
               <a:buNone/>
             </a:pPr>
             <a:r>
-              <a:rPr lang="en-US" sz="1450" b="1" i="1" dirty="0">
+              <a:rPr lang="en-US" sz="1400" b="1" i="1" dirty="0">
                 <a:solidFill>
                   <a:srgbClr val="6E1B2A"/>
                 </a:solidFill>
@@ -6089,9 +6089,9 @@
                 <a:ea typeface="Calibri" pitchFamily="34" charset="-122"/>
                 <a:cs typeface="Calibri" pitchFamily="34" charset="-120"/>
               </a:rPr>
-              <a:t>For every ₹1 you pay us, you keep ₹3–4 in savings — and our entire fee is less than the salary of two of the people you no longer need to hire.</a:t>
+              <a:t>You replace a ₹75,000–4,50,000 salary bill and still save ₹1.7–14 lakh a year — before Sneha wins you a single extra admission. Add the ones a missed call would have lost, and it isn’t close.</a:t>
             </a:r>
-            <a:endParaRPr lang="en-US" sz="1450" dirty="0"/>
+            <a:endParaRPr lang="en-US" sz="1400" dirty="0"/>
           </a:p>
         </p:txBody>
       </p:sp>
@@ -6128,7 +6128,7 @@
                 <a:ea typeface="Calibri" pitchFamily="34" charset="-122"/>
                 <a:cs typeface="Calibri" pitchFamily="34" charset="-120"/>
               </a:rPr>
-              <a:t>Vendor accounts in your name, bills visible to you, +GST as applicable. Monthly totals assume modelled call volumes; your real bill follows your real minutes. First-year saving net of one-time setup: ≈ ₹2,98,000 · ₹10,88,000 · ₹21,90,000.</a:t>
+              <a:t>Vendor accounts in your name, bills visible to you, +GST as applicable. Monthly totals assume modelled call volumes; your real bill follows your real minutes. First-year saving net of one-time setup: ≈ ₹1,18,000 · ₹4,88,000 · ₹12,90,000.</a:t>
             </a:r>
             <a:endParaRPr lang="en-US" sz="1050" dirty="0"/>
           </a:p>
@@ -6487,7 +6487,7 @@
                 <a:ea typeface="Cambria" pitchFamily="34" charset="-122"/>
                 <a:cs typeface="Cambria" pitchFamily="34" charset="-120"/>
               </a:rPr>
-              <a:t>₹1.2–6 lakh</a:t>
+              <a:t>₹3.5–16.5 lakh</a:t>
             </a:r>
             <a:endParaRPr lang="en-US" sz="2900" dirty="0"/>
           </a:p>
@@ -6631,7 +6631,7 @@
                 <a:ea typeface="Cambria" pitchFamily="34" charset="-122"/>
                 <a:cs typeface="Cambria" pitchFamily="34" charset="-120"/>
               </a:rPr>
-              <a:t>1–2 admissions</a:t>
+              <a:t>2–8 admissions</a:t>
             </a:r>
             <a:endParaRPr lang="en-US" sz="2900" dirty="0"/>
           </a:p>

</xml_diff>